<commit_message>
slides: update Slide 1 with live Streamlit app URL
</commit_message>
<xml_diff>
--- a/EarthSafe_Final_Presentation.pptx
+++ b/EarthSafe_Final_Presentation.pptx
@@ -2303,14 +2303,14 @@
               <a:buNone/>
             </a:pPr>
             <a:r>
-              <a:rPr lang="en-US" sz="1100" dirty="0">
+              <a:rPr lang="en-US" sz="950" dirty="0">
                 <a:solidFill>
                   <a:srgbClr val="FFFFFF"/>
                 </a:solidFill>
               </a:rPr>
-              <a:t>🔗  App: [link after deploy]</a:t>
-            </a:r>
-            <a:endParaRPr lang="en-US" sz="1100" dirty="0"/>
+              <a:t>🔗  earthsafe-eu9o2sytymwqnls48ppjg7.streamlit.app</a:t>
+            </a:r>
+            <a:endParaRPr lang="en-US" sz="950" dirty="0"/>
           </a:p>
         </p:txBody>
       </p:sp>
@@ -2366,14 +2366,14 @@
               <a:buNone/>
             </a:pPr>
             <a:r>
-              <a:rPr lang="en-US" sz="1100" dirty="0">
+              <a:rPr lang="en-US" sz="950" dirty="0">
                 <a:solidFill>
                   <a:srgbClr val="FFFFFF"/>
                 </a:solidFill>
               </a:rPr>
-              <a:t>⚙️  API: [link after deploy]</a:t>
-            </a:r>
-            <a:endParaRPr lang="en-US" sz="1100" dirty="0"/>
+              <a:t>⚙️  API: Flask · POST /predict  (local / Cloud Run)</a:t>
+            </a:r>
+            <a:endParaRPr lang="en-US" sz="950" dirty="0"/>
           </a:p>
         </p:txBody>
       </p:sp>

</xml_diff>

<commit_message>
feat: fulfill all final project requirements
- README: add live Streamlit URL, API usage examples, model results
  table, AI assistant documentation section (required deliverable)
- Slide 7: replace sample_weight item with Claude AI assistant mention
  (explicitly required by final-slides rubric)
- tests/test_api.py: 9 unit tests covering /health, /predict, /recent
  edge cases (400 validation, probability sum, label correctness)
- .github/workflows/ci.yml: CI pipeline — install, train, pytest
- src/api/app.py: add structured logging for predict + recent endpoints
- EarthSafe_Speech_Script.md/docx: add AI assistant talking point

Co-Authored-By: Claude Sonnet 4.6 <noreply@anthropic.com>
</commit_message>
<xml_diff>
--- a/EarthSafe_Final_Presentation.pptx
+++ b/EarthSafe_Final_Presentation.pptx
@@ -7104,7 +7104,7 @@
         <p:spPr>
           <a:xfrm>
             <a:off x="256032" y="1517904"/>
-            <a:ext cx="2816352" cy="713232"/>
+            <a:ext cx="2816352" cy="1024128"/>
           </a:xfrm>
           <a:prstGeom prst="rect">
             <a:avLst/>
@@ -7136,7 +7136,7 @@
         <p:spPr>
           <a:xfrm>
             <a:off x="256032" y="1517904"/>
-            <a:ext cx="91440" cy="713232"/>
+            <a:ext cx="91440" cy="1024128"/>
           </a:xfrm>
           <a:prstGeom prst="rect">
             <a:avLst/>
@@ -7160,8 +7160,8 @@
         </p:nvSpPr>
         <p:spPr>
           <a:xfrm>
-            <a:off x="420624" y="1572768"/>
-            <a:ext cx="2560320" cy="603504"/>
+            <a:off x="420624" y="1591056"/>
+            <a:ext cx="2560320" cy="877824"/>
           </a:xfrm>
           <a:prstGeom prst="rect">
             <a:avLst/>
@@ -7177,7 +7177,7 @@
               <a:buNone/>
             </a:pPr>
             <a:r>
-              <a:rPr lang="en-US" sz="1200" dirty="0">
+              <a:rPr lang="en-US" sz="1400" dirty="0">
                 <a:solidFill>
                   <a:srgbClr val="1A1A2A"/>
                 </a:solidFill>
@@ -7185,9 +7185,9 @@
                 <a:ea typeface="Calibri" pitchFamily="34" charset="-122"/>
                 <a:cs typeface="Calibri" pitchFamily="34" charset="-120"/>
               </a:rPr>
-              <a:t>Severe class imbalance — only 7 High-hazard events in 2,000 records</a:t>
-            </a:r>
-            <a:endParaRPr lang="en-US" sz="1200" dirty="0"/>
+              <a:t>Class imbalance — 7 High events / 2,000 records</a:t>
+            </a:r>
+            <a:endParaRPr lang="en-US" sz="1400" dirty="0"/>
           </a:p>
         </p:txBody>
       </p:sp>
@@ -7199,8 +7199,8 @@
         </p:nvSpPr>
         <p:spPr>
           <a:xfrm>
-            <a:off x="256032" y="2322576"/>
-            <a:ext cx="2816352" cy="713232"/>
+            <a:off x="256032" y="2615184"/>
+            <a:ext cx="2816352" cy="1024128"/>
           </a:xfrm>
           <a:prstGeom prst="rect">
             <a:avLst/>
@@ -7231,8 +7231,8 @@
         </p:nvSpPr>
         <p:spPr>
           <a:xfrm>
-            <a:off x="256032" y="2322576"/>
-            <a:ext cx="91440" cy="713232"/>
+            <a:off x="256032" y="2615184"/>
+            <a:ext cx="91440" cy="1024128"/>
           </a:xfrm>
           <a:prstGeom prst="rect">
             <a:avLst/>
@@ -7256,8 +7256,8 @@
         </p:nvSpPr>
         <p:spPr>
           <a:xfrm>
-            <a:off x="420624" y="2377440"/>
-            <a:ext cx="2560320" cy="603504"/>
+            <a:off x="420624" y="2688336"/>
+            <a:ext cx="2560320" cy="877824"/>
           </a:xfrm>
           <a:prstGeom prst="rect">
             <a:avLst/>
@@ -7273,7 +7273,7 @@
               <a:buNone/>
             </a:pPr>
             <a:r>
-              <a:rPr lang="en-US" sz="1200" dirty="0">
+              <a:rPr lang="en-US" sz="1400" dirty="0">
                 <a:solidFill>
                   <a:srgbClr val="1A1A2A"/>
                 </a:solidFill>
@@ -7281,9 +7281,9 @@
                 <a:ea typeface="Calibri" pitchFamily="34" charset="-122"/>
                 <a:cs typeface="Calibri" pitchFamily="34" charset="-120"/>
               </a:rPr>
-              <a:t>macOS port 5000 blocked by AirPlay — migrated Flask API to port 5001</a:t>
-            </a:r>
-            <a:endParaRPr lang="en-US" sz="1200" dirty="0"/>
+              <a:t>Port 5000 blocked → Flask moved to 5001</a:t>
+            </a:r>
+            <a:endParaRPr lang="en-US" sz="1400" dirty="0"/>
           </a:p>
         </p:txBody>
       </p:sp>
@@ -7295,8 +7295,8 @@
         </p:nvSpPr>
         <p:spPr>
           <a:xfrm>
-            <a:off x="256032" y="3127248"/>
-            <a:ext cx="2816352" cy="713232"/>
+            <a:off x="256032" y="3712464"/>
+            <a:ext cx="2816352" cy="1024128"/>
           </a:xfrm>
           <a:prstGeom prst="rect">
             <a:avLst/>
@@ -7327,8 +7327,8 @@
         </p:nvSpPr>
         <p:spPr>
           <a:xfrm>
-            <a:off x="256032" y="3127248"/>
-            <a:ext cx="91440" cy="713232"/>
+            <a:off x="256032" y="3712464"/>
+            <a:ext cx="91440" cy="1024128"/>
           </a:xfrm>
           <a:prstGeom prst="rect">
             <a:avLst/>
@@ -7352,8 +7352,8 @@
         </p:nvSpPr>
         <p:spPr>
           <a:xfrm>
-            <a:off x="420624" y="3182112"/>
-            <a:ext cx="2560320" cy="603504"/>
+            <a:off x="420624" y="3785616"/>
+            <a:ext cx="2560320" cy="877824"/>
           </a:xfrm>
           <a:prstGeom prst="rect">
             <a:avLst/>
@@ -7369,7 +7369,7 @@
               <a:buNone/>
             </a:pPr>
             <a:r>
-              <a:rPr lang="en-US" sz="1200" dirty="0">
+              <a:rPr lang="en-US" sz="1400" dirty="0">
                 <a:solidFill>
                   <a:srgbClr val="1A1A2A"/>
                 </a:solidFill>
@@ -7377,111 +7377,15 @@
                 <a:ea typeface="Calibri" pitchFamily="34" charset="-122"/>
                 <a:cs typeface="Calibri" pitchFamily="34" charset="-120"/>
               </a:rPr>
-              <a:t>XGBoost requires brew install libomp on macOS for OpenMP support</a:t>
-            </a:r>
-            <a:endParaRPr lang="en-US" sz="1200" dirty="0"/>
+              <a:t>XGBoost on Mac — brew install libomp</a:t>
+            </a:r>
+            <a:endParaRPr lang="en-US" sz="1400" dirty="0"/>
           </a:p>
         </p:txBody>
       </p:sp>
       <p:sp>
         <p:nvSpPr>
           <p:cNvPr id="16" name="Shape 14"/>
-          <p:cNvSpPr/>
-          <p:nvPr/>
-        </p:nvSpPr>
-        <p:spPr>
-          <a:xfrm>
-            <a:off x="256032" y="3931920"/>
-            <a:ext cx="2816352" cy="713232"/>
-          </a:xfrm>
-          <a:prstGeom prst="rect">
-            <a:avLst/>
-          </a:prstGeom>
-          <a:solidFill>
-            <a:srgbClr val="FDEDEC"/>
-          </a:solidFill>
-          <a:ln w="12700">
-            <a:solidFill>
-              <a:srgbClr val="F5B7B1"/>
-            </a:solidFill>
-            <a:prstDash val="solid"/>
-          </a:ln>
-          <a:effectLst>
-            <a:outerShdw sx="100000" sy="100000" kx="0" ky="0" algn="bl" rotWithShape="0" blurRad="127000" dist="38100" dir="8100000">
-              <a:srgbClr val="000000">
-                <a:alpha val="10000"/>
-              </a:srgbClr>
-            </a:outerShdw>
-          </a:effectLst>
-        </p:spPr>
-      </p:sp>
-      <p:sp>
-        <p:nvSpPr>
-          <p:cNvPr id="17" name="Shape 15"/>
-          <p:cNvSpPr/>
-          <p:nvPr/>
-        </p:nvSpPr>
-        <p:spPr>
-          <a:xfrm>
-            <a:off x="256032" y="3931920"/>
-            <a:ext cx="91440" cy="713232"/>
-          </a:xfrm>
-          <a:prstGeom prst="rect">
-            <a:avLst/>
-          </a:prstGeom>
-          <a:solidFill>
-            <a:srgbClr val="C0392B"/>
-          </a:solidFill>
-          <a:ln w="12700">
-            <a:solidFill>
-              <a:srgbClr val="C0392B"/>
-            </a:solidFill>
-            <a:prstDash val="solid"/>
-          </a:ln>
-        </p:spPr>
-      </p:sp>
-      <p:sp>
-        <p:nvSpPr>
-          <p:cNvPr id="18" name="Text 16"/>
-          <p:cNvSpPr/>
-          <p:nvPr/>
-        </p:nvSpPr>
-        <p:spPr>
-          <a:xfrm>
-            <a:off x="420624" y="3986784"/>
-            <a:ext cx="2560320" cy="603504"/>
-          </a:xfrm>
-          <a:prstGeom prst="rect">
-            <a:avLst/>
-          </a:prstGeom>
-          <a:noFill/>
-          <a:ln/>
-        </p:spPr>
-        <p:txBody>
-          <a:bodyPr wrap="square" rtlCol="0" anchor="ctr"/>
-          <a:lstStyle/>
-          <a:p>
-            <a:pPr indent="0" marL="0">
-              <a:buNone/>
-            </a:pPr>
-            <a:r>
-              <a:rPr lang="en-US" sz="1200" dirty="0">
-                <a:solidFill>
-                  <a:srgbClr val="1A1A2A"/>
-                </a:solidFill>
-                <a:latin typeface="Calibri" pitchFamily="34" charset="0"/>
-                <a:ea typeface="Calibri" pitchFamily="34" charset="-122"/>
-                <a:cs typeface="Calibri" pitchFamily="34" charset="-120"/>
-              </a:rPr>
-              <a:t>USGS 20k/request limit — solved with monthly chunk fetching</a:t>
-            </a:r>
-            <a:endParaRPr lang="en-US" sz="1200" dirty="0"/>
-          </a:p>
-        </p:txBody>
-      </p:sp>
-      <p:sp>
-        <p:nvSpPr>
-          <p:cNvPr id="19" name="Shape 17"/>
           <p:cNvSpPr/>
           <p:nvPr/>
         </p:nvSpPr>
@@ -7506,7 +7410,7 @@
       </p:sp>
       <p:sp>
         <p:nvSpPr>
-          <p:cNvPr id="20" name="Text 18"/>
+          <p:cNvPr id="17" name="Text 15"/>
           <p:cNvSpPr/>
           <p:nvPr/>
         </p:nvSpPr>
@@ -7545,14 +7449,14 @@
       </p:sp>
       <p:sp>
         <p:nvSpPr>
-          <p:cNvPr id="21" name="Shape 19"/>
+          <p:cNvPr id="18" name="Shape 16"/>
           <p:cNvSpPr/>
           <p:nvPr/>
         </p:nvSpPr>
         <p:spPr>
           <a:xfrm>
             <a:off x="3218688" y="1517904"/>
-            <a:ext cx="2816352" cy="713232"/>
+            <a:ext cx="2816352" cy="1024128"/>
           </a:xfrm>
           <a:prstGeom prst="rect">
             <a:avLst/>
@@ -7577,14 +7481,14 @@
       </p:sp>
       <p:sp>
         <p:nvSpPr>
-          <p:cNvPr id="22" name="Shape 20"/>
+          <p:cNvPr id="19" name="Shape 17"/>
           <p:cNvSpPr/>
           <p:nvPr/>
         </p:nvSpPr>
         <p:spPr>
           <a:xfrm>
             <a:off x="3218688" y="1517904"/>
-            <a:ext cx="91440" cy="713232"/>
+            <a:ext cx="91440" cy="1024128"/>
           </a:xfrm>
           <a:prstGeom prst="rect">
             <a:avLst/>
@@ -7602,14 +7506,14 @@
       </p:sp>
       <p:sp>
         <p:nvSpPr>
-          <p:cNvPr id="23" name="Text 21"/>
-          <p:cNvSpPr/>
-          <p:nvPr/>
-        </p:nvSpPr>
-        <p:spPr>
-          <a:xfrm>
-            <a:off x="3383280" y="1572768"/>
-            <a:ext cx="2560320" cy="603504"/>
+          <p:cNvPr id="20" name="Text 18"/>
+          <p:cNvSpPr/>
+          <p:nvPr/>
+        </p:nvSpPr>
+        <p:spPr>
+          <a:xfrm>
+            <a:off x="3383280" y="1591056"/>
+            <a:ext cx="2560320" cy="877824"/>
           </a:xfrm>
           <a:prstGeom prst="rect">
             <a:avLst/>
@@ -7625,7 +7529,7 @@
               <a:buNone/>
             </a:pPr>
             <a:r>
-              <a:rPr lang="en-US" sz="1200" dirty="0">
+              <a:rPr lang="en-US" sz="1400" dirty="0">
                 <a:solidFill>
                   <a:srgbClr val="1A1A2A"/>
                 </a:solidFill>
@@ -7633,22 +7537,22 @@
                 <a:ea typeface="Calibri" pitchFamily="34" charset="-122"/>
                 <a:cs typeface="Calibri" pitchFamily="34" charset="-120"/>
               </a:rPr>
-              <a:t>Full MLOps pipeline in one project: collect → train → API → UI → cloud</a:t>
-            </a:r>
-            <a:endParaRPr lang="en-US" sz="1200" dirty="0"/>
-          </a:p>
-        </p:txBody>
-      </p:sp>
-      <p:sp>
-        <p:nvSpPr>
-          <p:cNvPr id="24" name="Shape 22"/>
-          <p:cNvSpPr/>
-          <p:nvPr/>
-        </p:nvSpPr>
-        <p:spPr>
-          <a:xfrm>
-            <a:off x="3218688" y="2322576"/>
-            <a:ext cx="2816352" cy="713232"/>
+              <a:t>Full MLOps: data → model → API → UI → cloud</a:t>
+            </a:r>
+            <a:endParaRPr lang="en-US" sz="1400" dirty="0"/>
+          </a:p>
+        </p:txBody>
+      </p:sp>
+      <p:sp>
+        <p:nvSpPr>
+          <p:cNvPr id="21" name="Shape 19"/>
+          <p:cNvSpPr/>
+          <p:nvPr/>
+        </p:nvSpPr>
+        <p:spPr>
+          <a:xfrm>
+            <a:off x="3218688" y="2615184"/>
+            <a:ext cx="2816352" cy="1024128"/>
           </a:xfrm>
           <a:prstGeom prst="rect">
             <a:avLst/>
@@ -7673,14 +7577,14 @@
       </p:sp>
       <p:sp>
         <p:nvSpPr>
-          <p:cNvPr id="25" name="Shape 23"/>
-          <p:cNvSpPr/>
-          <p:nvPr/>
-        </p:nvSpPr>
-        <p:spPr>
-          <a:xfrm>
-            <a:off x="3218688" y="2322576"/>
-            <a:ext cx="91440" cy="713232"/>
+          <p:cNvPr id="22" name="Shape 20"/>
+          <p:cNvSpPr/>
+          <p:nvPr/>
+        </p:nvSpPr>
+        <p:spPr>
+          <a:xfrm>
+            <a:off x="3218688" y="2615184"/>
+            <a:ext cx="91440" cy="1024128"/>
           </a:xfrm>
           <a:prstGeom prst="rect">
             <a:avLst/>
@@ -7698,14 +7602,14 @@
       </p:sp>
       <p:sp>
         <p:nvSpPr>
-          <p:cNvPr id="26" name="Text 24"/>
-          <p:cNvSpPr/>
-          <p:nvPr/>
-        </p:nvSpPr>
-        <p:spPr>
-          <a:xfrm>
-            <a:off x="3383280" y="2377440"/>
-            <a:ext cx="2560320" cy="603504"/>
+          <p:cNvPr id="23" name="Text 21"/>
+          <p:cNvSpPr/>
+          <p:nvPr/>
+        </p:nvSpPr>
+        <p:spPr>
+          <a:xfrm>
+            <a:off x="3383280" y="2688336"/>
+            <a:ext cx="2560320" cy="877824"/>
           </a:xfrm>
           <a:prstGeom prst="rect">
             <a:avLst/>
@@ -7721,7 +7625,7 @@
               <a:buNone/>
             </a:pPr>
             <a:r>
-              <a:rPr lang="en-US" sz="1200" dirty="0">
+              <a:rPr lang="en-US" sz="1400" dirty="0">
                 <a:solidFill>
                   <a:srgbClr val="1A1A2A"/>
                 </a:solidFill>
@@ -7729,22 +7633,22 @@
                 <a:ea typeface="Calibri" pitchFamily="34" charset="-122"/>
                 <a:cs typeface="Calibri" pitchFamily="34" charset="-120"/>
               </a:rPr>
-              <a:t>Macro F1 is the right metric for imbalanced multiclass, not accuracy</a:t>
-            </a:r>
-            <a:endParaRPr lang="en-US" sz="1200" dirty="0"/>
-          </a:p>
-        </p:txBody>
-      </p:sp>
-      <p:sp>
-        <p:nvSpPr>
-          <p:cNvPr id="27" name="Shape 25"/>
-          <p:cNvSpPr/>
-          <p:nvPr/>
-        </p:nvSpPr>
-        <p:spPr>
-          <a:xfrm>
-            <a:off x="3218688" y="3127248"/>
-            <a:ext cx="2816352" cy="713232"/>
+              <a:t>Macro F1 &gt; accuracy on imbalanced data</a:t>
+            </a:r>
+            <a:endParaRPr lang="en-US" sz="1400" dirty="0"/>
+          </a:p>
+        </p:txBody>
+      </p:sp>
+      <p:sp>
+        <p:nvSpPr>
+          <p:cNvPr id="24" name="Shape 22"/>
+          <p:cNvSpPr/>
+          <p:nvPr/>
+        </p:nvSpPr>
+        <p:spPr>
+          <a:xfrm>
+            <a:off x="3218688" y="3712464"/>
+            <a:ext cx="2816352" cy="1024128"/>
           </a:xfrm>
           <a:prstGeom prst="rect">
             <a:avLst/>
@@ -7769,14 +7673,14 @@
       </p:sp>
       <p:sp>
         <p:nvSpPr>
-          <p:cNvPr id="28" name="Shape 26"/>
-          <p:cNvSpPr/>
-          <p:nvPr/>
-        </p:nvSpPr>
-        <p:spPr>
-          <a:xfrm>
-            <a:off x="3218688" y="3127248"/>
-            <a:ext cx="91440" cy="713232"/>
+          <p:cNvPr id="25" name="Shape 23"/>
+          <p:cNvSpPr/>
+          <p:nvPr/>
+        </p:nvSpPr>
+        <p:spPr>
+          <a:xfrm>
+            <a:off x="3218688" y="3712464"/>
+            <a:ext cx="91440" cy="1024128"/>
           </a:xfrm>
           <a:prstGeom prst="rect">
             <a:avLst/>
@@ -7794,14 +7698,14 @@
       </p:sp>
       <p:sp>
         <p:nvSpPr>
-          <p:cNvPr id="29" name="Text 27"/>
-          <p:cNvSpPr/>
-          <p:nvPr/>
-        </p:nvSpPr>
-        <p:spPr>
-          <a:xfrm>
-            <a:off x="3383280" y="3182112"/>
-            <a:ext cx="2560320" cy="603504"/>
+          <p:cNvPr id="26" name="Text 24"/>
+          <p:cNvSpPr/>
+          <p:nvPr/>
+        </p:nvSpPr>
+        <p:spPr>
+          <a:xfrm>
+            <a:off x="3383280" y="3785616"/>
+            <a:ext cx="2560320" cy="877824"/>
           </a:xfrm>
           <a:prstGeom prst="rect">
             <a:avLst/>
@@ -7817,7 +7721,7 @@
               <a:buNone/>
             </a:pPr>
             <a:r>
-              <a:rPr lang="en-US" sz="1200" dirty="0">
+              <a:rPr lang="en-US" sz="1400" dirty="0">
                 <a:solidFill>
                   <a:srgbClr val="1A1A2A"/>
                 </a:solidFill>
@@ -7825,111 +7729,15 @@
                 <a:ea typeface="Calibri" pitchFamily="34" charset="-122"/>
                 <a:cs typeface="Calibri" pitchFamily="34" charset="-120"/>
               </a:rPr>
-              <a:t>Docker health checks + depends_on for reliable multi-service startup</a:t>
-            </a:r>
-            <a:endParaRPr lang="en-US" sz="1200" dirty="0"/>
-          </a:p>
-        </p:txBody>
-      </p:sp>
-      <p:sp>
-        <p:nvSpPr>
-          <p:cNvPr id="30" name="Shape 28"/>
-          <p:cNvSpPr/>
-          <p:nvPr/>
-        </p:nvSpPr>
-        <p:spPr>
-          <a:xfrm>
-            <a:off x="3218688" y="3931920"/>
-            <a:ext cx="2816352" cy="713232"/>
-          </a:xfrm>
-          <a:prstGeom prst="rect">
-            <a:avLst/>
-          </a:prstGeom>
-          <a:solidFill>
-            <a:srgbClr val="E0F5F2"/>
-          </a:solidFill>
-          <a:ln w="12700">
-            <a:solidFill>
-              <a:srgbClr val="A2D9CE"/>
-            </a:solidFill>
-            <a:prstDash val="solid"/>
-          </a:ln>
-          <a:effectLst>
-            <a:outerShdw sx="100000" sy="100000" kx="0" ky="0" algn="bl" rotWithShape="0" blurRad="127000" dist="38100" dir="8100000">
-              <a:srgbClr val="000000">
-                <a:alpha val="10000"/>
-              </a:srgbClr>
-            </a:outerShdw>
-          </a:effectLst>
-        </p:spPr>
-      </p:sp>
-      <p:sp>
-        <p:nvSpPr>
-          <p:cNvPr id="31" name="Shape 29"/>
-          <p:cNvSpPr/>
-          <p:nvPr/>
-        </p:nvSpPr>
-        <p:spPr>
-          <a:xfrm>
-            <a:off x="3218688" y="3931920"/>
-            <a:ext cx="91440" cy="713232"/>
-          </a:xfrm>
-          <a:prstGeom prst="rect">
-            <a:avLst/>
-          </a:prstGeom>
-          <a:solidFill>
-            <a:srgbClr val="0D9488"/>
-          </a:solidFill>
-          <a:ln w="12700">
-            <a:solidFill>
-              <a:srgbClr val="0D9488"/>
-            </a:solidFill>
-            <a:prstDash val="solid"/>
-          </a:ln>
-        </p:spPr>
-      </p:sp>
-      <p:sp>
-        <p:nvSpPr>
-          <p:cNvPr id="32" name="Text 30"/>
-          <p:cNvSpPr/>
-          <p:nvPr/>
-        </p:nvSpPr>
-        <p:spPr>
-          <a:xfrm>
-            <a:off x="3383280" y="3986784"/>
-            <a:ext cx="2560320" cy="603504"/>
-          </a:xfrm>
-          <a:prstGeom prst="rect">
-            <a:avLst/>
-          </a:prstGeom>
-          <a:noFill/>
-          <a:ln/>
-        </p:spPr>
-        <p:txBody>
-          <a:bodyPr wrap="square" rtlCol="0" anchor="ctr"/>
-          <a:lstStyle/>
-          <a:p>
-            <a:pPr indent="0" marL="0">
-              <a:buNone/>
-            </a:pPr>
-            <a:r>
-              <a:rPr lang="en-US" sz="1200" dirty="0">
-                <a:solidFill>
-                  <a:srgbClr val="1A1A2A"/>
-                </a:solidFill>
-                <a:latin typeface="Calibri" pitchFamily="34" charset="0"/>
-                <a:ea typeface="Calibri" pitchFamily="34" charset="-122"/>
-                <a:cs typeface="Calibri" pitchFamily="34" charset="-120"/>
-              </a:rPr>
-              <a:t>XGBoost sample_weight more robust than class_weight for rare classes</a:t>
-            </a:r>
-            <a:endParaRPr lang="en-US" sz="1200" dirty="0"/>
-          </a:p>
-        </p:txBody>
-      </p:sp>
-      <p:sp>
-        <p:nvSpPr>
-          <p:cNvPr id="33" name="Shape 31"/>
+              <a:t>Claude AI: code, debug &amp; deploy at every layer</a:t>
+            </a:r>
+            <a:endParaRPr lang="en-US" sz="1400" dirty="0"/>
+          </a:p>
+        </p:txBody>
+      </p:sp>
+      <p:sp>
+        <p:nvSpPr>
+          <p:cNvPr id="27" name="Shape 25"/>
           <p:cNvSpPr/>
           <p:nvPr/>
         </p:nvSpPr>
@@ -7954,7 +7762,7 @@
       </p:sp>
       <p:sp>
         <p:nvSpPr>
-          <p:cNvPr id="34" name="Text 32"/>
+          <p:cNvPr id="28" name="Text 26"/>
           <p:cNvSpPr/>
           <p:nvPr/>
         </p:nvSpPr>
@@ -7993,14 +7801,14 @@
       </p:sp>
       <p:sp>
         <p:nvSpPr>
-          <p:cNvPr id="35" name="Shape 33"/>
+          <p:cNvPr id="29" name="Shape 27"/>
           <p:cNvSpPr/>
           <p:nvPr/>
         </p:nvSpPr>
         <p:spPr>
           <a:xfrm>
             <a:off x="6181344" y="1517904"/>
-            <a:ext cx="2816352" cy="713232"/>
+            <a:ext cx="2816352" cy="1024128"/>
           </a:xfrm>
           <a:prstGeom prst="rect">
             <a:avLst/>
@@ -8025,14 +7833,14 @@
       </p:sp>
       <p:sp>
         <p:nvSpPr>
-          <p:cNvPr id="36" name="Shape 34"/>
+          <p:cNvPr id="30" name="Shape 28"/>
           <p:cNvSpPr/>
           <p:nvPr/>
         </p:nvSpPr>
         <p:spPr>
           <a:xfrm>
             <a:off x="6181344" y="1517904"/>
-            <a:ext cx="91440" cy="713232"/>
+            <a:ext cx="91440" cy="1024128"/>
           </a:xfrm>
           <a:prstGeom prst="rect">
             <a:avLst/>
@@ -8050,14 +7858,14 @@
       </p:sp>
       <p:sp>
         <p:nvSpPr>
-          <p:cNvPr id="37" name="Text 35"/>
-          <p:cNvSpPr/>
-          <p:nvPr/>
-        </p:nvSpPr>
-        <p:spPr>
-          <a:xfrm>
-            <a:off x="6345936" y="1572768"/>
-            <a:ext cx="2560320" cy="603504"/>
+          <p:cNvPr id="31" name="Text 29"/>
+          <p:cNvSpPr/>
+          <p:nvPr/>
+        </p:nvSpPr>
+        <p:spPr>
+          <a:xfrm>
+            <a:off x="6345936" y="1591056"/>
+            <a:ext cx="2560320" cy="877824"/>
           </a:xfrm>
           <a:prstGeom prst="rect">
             <a:avLst/>
@@ -8073,7 +7881,7 @@
               <a:buNone/>
             </a:pPr>
             <a:r>
-              <a:rPr lang="en-US" sz="1200" dirty="0">
+              <a:rPr lang="en-US" sz="1400" dirty="0">
                 <a:solidFill>
                   <a:srgbClr val="1A1A2A"/>
                 </a:solidFill>
@@ -8081,22 +7889,22 @@
                 <a:ea typeface="Calibri" pitchFamily="34" charset="-122"/>
                 <a:cs typeface="Calibri" pitchFamily="34" charset="-120"/>
               </a:rPr>
-              <a:t>Add temporal features — aftershock sequences, time since last event</a:t>
-            </a:r>
-            <a:endParaRPr lang="en-US" sz="1200" dirty="0"/>
-          </a:p>
-        </p:txBody>
-      </p:sp>
-      <p:sp>
-        <p:nvSpPr>
-          <p:cNvPr id="38" name="Shape 36"/>
-          <p:cNvSpPr/>
-          <p:nvPr/>
-        </p:nvSpPr>
-        <p:spPr>
-          <a:xfrm>
-            <a:off x="6181344" y="2322576"/>
-            <a:ext cx="2816352" cy="713232"/>
+              <a:t>Temporal features — aftershock sequences</a:t>
+            </a:r>
+            <a:endParaRPr lang="en-US" sz="1400" dirty="0"/>
+          </a:p>
+        </p:txBody>
+      </p:sp>
+      <p:sp>
+        <p:nvSpPr>
+          <p:cNvPr id="32" name="Shape 30"/>
+          <p:cNvSpPr/>
+          <p:nvPr/>
+        </p:nvSpPr>
+        <p:spPr>
+          <a:xfrm>
+            <a:off x="6181344" y="2615184"/>
+            <a:ext cx="2816352" cy="1024128"/>
           </a:xfrm>
           <a:prstGeom prst="rect">
             <a:avLst/>
@@ -8121,14 +7929,14 @@
       </p:sp>
       <p:sp>
         <p:nvSpPr>
-          <p:cNvPr id="39" name="Shape 37"/>
-          <p:cNvSpPr/>
-          <p:nvPr/>
-        </p:nvSpPr>
-        <p:spPr>
-          <a:xfrm>
-            <a:off x="6181344" y="2322576"/>
-            <a:ext cx="91440" cy="713232"/>
+          <p:cNvPr id="33" name="Shape 31"/>
+          <p:cNvSpPr/>
+          <p:nvPr/>
+        </p:nvSpPr>
+        <p:spPr>
+          <a:xfrm>
+            <a:off x="6181344" y="2615184"/>
+            <a:ext cx="91440" cy="1024128"/>
           </a:xfrm>
           <a:prstGeom prst="rect">
             <a:avLst/>
@@ -8146,14 +7954,14 @@
       </p:sp>
       <p:sp>
         <p:nvSpPr>
-          <p:cNvPr id="40" name="Text 38"/>
-          <p:cNvSpPr/>
-          <p:nvPr/>
-        </p:nvSpPr>
-        <p:spPr>
-          <a:xfrm>
-            <a:off x="6345936" y="2377440"/>
-            <a:ext cx="2560320" cy="603504"/>
+          <p:cNvPr id="34" name="Text 32"/>
+          <p:cNvSpPr/>
+          <p:nvPr/>
+        </p:nvSpPr>
+        <p:spPr>
+          <a:xfrm>
+            <a:off x="6345936" y="2688336"/>
+            <a:ext cx="2560320" cy="877824"/>
           </a:xfrm>
           <a:prstGeom prst="rect">
             <a:avLst/>
@@ -8169,7 +7977,7 @@
               <a:buNone/>
             </a:pPr>
             <a:r>
-              <a:rPr lang="en-US" sz="1200" dirty="0">
+              <a:rPr lang="en-US" sz="1400" dirty="0">
                 <a:solidFill>
                   <a:srgbClr val="1A1A2A"/>
                 </a:solidFill>
@@ -8177,22 +7985,22 @@
                 <a:ea typeface="Calibri" pitchFamily="34" charset="-122"/>
                 <a:cs typeface="Calibri" pitchFamily="34" charset="-120"/>
               </a:rPr>
-              <a:t>USGS WebSocket feed for sub-second real-time map updates</a:t>
-            </a:r>
-            <a:endParaRPr lang="en-US" sz="1200" dirty="0"/>
-          </a:p>
-        </p:txBody>
-      </p:sp>
-      <p:sp>
-        <p:nvSpPr>
-          <p:cNvPr id="41" name="Shape 39"/>
-          <p:cNvSpPr/>
-          <p:nvPr/>
-        </p:nvSpPr>
-        <p:spPr>
-          <a:xfrm>
-            <a:off x="6181344" y="3127248"/>
-            <a:ext cx="2816352" cy="713232"/>
+              <a:t>USGS WebSocket — sub-second map updates</a:t>
+            </a:r>
+            <a:endParaRPr lang="en-US" sz="1400" dirty="0"/>
+          </a:p>
+        </p:txBody>
+      </p:sp>
+      <p:sp>
+        <p:nvSpPr>
+          <p:cNvPr id="35" name="Shape 33"/>
+          <p:cNvSpPr/>
+          <p:nvPr/>
+        </p:nvSpPr>
+        <p:spPr>
+          <a:xfrm>
+            <a:off x="6181344" y="3712464"/>
+            <a:ext cx="2816352" cy="1024128"/>
           </a:xfrm>
           <a:prstGeom prst="rect">
             <a:avLst/>
@@ -8217,14 +8025,14 @@
       </p:sp>
       <p:sp>
         <p:nvSpPr>
-          <p:cNvPr id="42" name="Shape 40"/>
-          <p:cNvSpPr/>
-          <p:nvPr/>
-        </p:nvSpPr>
-        <p:spPr>
-          <a:xfrm>
-            <a:off x="6181344" y="3127248"/>
-            <a:ext cx="91440" cy="713232"/>
+          <p:cNvPr id="36" name="Shape 34"/>
+          <p:cNvSpPr/>
+          <p:nvPr/>
+        </p:nvSpPr>
+        <p:spPr>
+          <a:xfrm>
+            <a:off x="6181344" y="3712464"/>
+            <a:ext cx="91440" cy="1024128"/>
           </a:xfrm>
           <a:prstGeom prst="rect">
             <a:avLst/>
@@ -8242,14 +8050,14 @@
       </p:sp>
       <p:sp>
         <p:nvSpPr>
-          <p:cNvPr id="43" name="Text 41"/>
-          <p:cNvSpPr/>
-          <p:nvPr/>
-        </p:nvSpPr>
-        <p:spPr>
-          <a:xfrm>
-            <a:off x="6345936" y="3182112"/>
-            <a:ext cx="2560320" cy="603504"/>
+          <p:cNvPr id="37" name="Text 35"/>
+          <p:cNvSpPr/>
+          <p:nvPr/>
+        </p:nvSpPr>
+        <p:spPr>
+          <a:xfrm>
+            <a:off x="6345936" y="3785616"/>
+            <a:ext cx="2560320" cy="877824"/>
           </a:xfrm>
           <a:prstGeom prst="rect">
             <a:avLst/>
@@ -8265,7 +8073,7 @@
               <a:buNone/>
             </a:pPr>
             <a:r>
-              <a:rPr lang="en-US" sz="1200" dirty="0">
+              <a:rPr lang="en-US" sz="1400" dirty="0">
                 <a:solidFill>
                   <a:srgbClr val="1A1A2A"/>
                 </a:solidFill>
@@ -8273,111 +8081,15 @@
                 <a:ea typeface="Calibri" pitchFamily="34" charset="-122"/>
                 <a:cs typeface="Calibri" pitchFamily="34" charset="-120"/>
               </a:rPr>
-              <a:t>Expand to regression: predict magnitude from early seismic signals</a:t>
-            </a:r>
-            <a:endParaRPr lang="en-US" sz="1200" dirty="0"/>
-          </a:p>
-        </p:txBody>
-      </p:sp>
-      <p:sp>
-        <p:nvSpPr>
-          <p:cNvPr id="44" name="Shape 42"/>
-          <p:cNvSpPr/>
-          <p:nvPr/>
-        </p:nvSpPr>
-        <p:spPr>
-          <a:xfrm>
-            <a:off x="6181344" y="3931920"/>
-            <a:ext cx="2816352" cy="713232"/>
-          </a:xfrm>
-          <a:prstGeom prst="rect">
-            <a:avLst/>
-          </a:prstGeom>
-          <a:solidFill>
-            <a:srgbClr val="EAF4FB"/>
-          </a:solidFill>
-          <a:ln w="12700">
-            <a:solidFill>
-              <a:srgbClr val="B2D8F0"/>
-            </a:solidFill>
-            <a:prstDash val="solid"/>
-          </a:ln>
-          <a:effectLst>
-            <a:outerShdw sx="100000" sy="100000" kx="0" ky="0" algn="bl" rotWithShape="0" blurRad="127000" dist="38100" dir="8100000">
-              <a:srgbClr val="000000">
-                <a:alpha val="10000"/>
-              </a:srgbClr>
-            </a:outerShdw>
-          </a:effectLst>
-        </p:spPr>
-      </p:sp>
-      <p:sp>
-        <p:nvSpPr>
-          <p:cNvPr id="45" name="Shape 43"/>
-          <p:cNvSpPr/>
-          <p:nvPr/>
-        </p:nvSpPr>
-        <p:spPr>
-          <a:xfrm>
-            <a:off x="6181344" y="3931920"/>
-            <a:ext cx="91440" cy="713232"/>
-          </a:xfrm>
-          <a:prstGeom prst="rect">
-            <a:avLst/>
-          </a:prstGeom>
-          <a:solidFill>
-            <a:srgbClr val="1A5276"/>
-          </a:solidFill>
-          <a:ln w="12700">
-            <a:solidFill>
-              <a:srgbClr val="1A5276"/>
-            </a:solidFill>
-            <a:prstDash val="solid"/>
-          </a:ln>
-        </p:spPr>
-      </p:sp>
-      <p:sp>
-        <p:nvSpPr>
-          <p:cNvPr id="46" name="Text 44"/>
-          <p:cNvSpPr/>
-          <p:nvPr/>
-        </p:nvSpPr>
-        <p:spPr>
-          <a:xfrm>
-            <a:off x="6345936" y="3986784"/>
-            <a:ext cx="2560320" cy="603504"/>
-          </a:xfrm>
-          <a:prstGeom prst="rect">
-            <a:avLst/>
-          </a:prstGeom>
-          <a:noFill/>
-          <a:ln/>
-        </p:spPr>
-        <p:txBody>
-          <a:bodyPr wrap="square" rtlCol="0" anchor="ctr"/>
-          <a:lstStyle/>
-          <a:p>
-            <a:pPr indent="0" marL="0">
-              <a:buNone/>
-            </a:pPr>
-            <a:r>
-              <a:rPr lang="en-US" sz="1200" dirty="0">
-                <a:solidFill>
-                  <a:srgbClr val="1A1A2A"/>
-                </a:solidFill>
-                <a:latin typeface="Calibri" pitchFamily="34" charset="0"/>
-                <a:ea typeface="Calibri" pitchFamily="34" charset="-122"/>
-                <a:cs typeface="Calibri" pitchFamily="34" charset="-120"/>
-              </a:rPr>
-              <a:t>Geospatial clustering — fault line proximity as an engineered feature</a:t>
-            </a:r>
-            <a:endParaRPr lang="en-US" sz="1200" dirty="0"/>
-          </a:p>
-        </p:txBody>
-      </p:sp>
-      <p:sp>
-        <p:nvSpPr>
-          <p:cNvPr id="47" name="Text 45"/>
+              <a:t>Magnitude regression — early warning</a:t>
+            </a:r>
+            <a:endParaRPr lang="en-US" sz="1400" dirty="0"/>
+          </a:p>
+        </p:txBody>
+      </p:sp>
+      <p:sp>
+        <p:nvSpPr>
+          <p:cNvPr id="38" name="Text 36"/>
           <p:cNvSpPr/>
           <p:nvPr/>
         </p:nvSpPr>

</xml_diff>